<commit_message>
Add consulting-type mix charts (group vs external share, overall donut)
Co-Authored-By: Claude Opus 5.5 <noreply@anthropic.com>
Claude-Session: https://claude.ai/code/session_014bmYQ2fMPYk9mSnunBW5W4
</commit_message>
<xml_diff>
--- a/25-26_연도별_활동추이.pptx
+++ b/25-26_연도별_활동추이.pptx
@@ -858,6 +858,275 @@
         </a:p>
       </c:txPr>
     </c:legend>
+    <c:plotVisOnly val="1"/>
+    <c:dispBlanksAs val="span"/>
+  </c:chart>
+  <c:spPr>
+    <a:noFill/>
+    <a:ln>
+      <a:noFill/>
+    </a:ln>
+    <a:effectLst/>
+  </c:spPr>
+  <c:externalData r:id="rId1">
+    <c:autoUpdate val="0"/>
+  </c:externalData>
+</c:chartSpace>
+</file>
+
+<file path=ppt/charts/chart2.xml><?xml version="1.0" encoding="utf-8"?>
+<c:chartSpace xmlns:c="http://schemas.openxmlformats.org/drawingml/2006/chart" xmlns:a="http://schemas.openxmlformats.org/drawingml/2006/main" xmlns:r="http://schemas.openxmlformats.org/officeDocument/2006/relationships">
+  <c:date1904 val="0"/>
+  <c:roundedCorners val="1"/>
+  <c:chart>
+    <c:autoTitleDeleted val="1"/>
+    <c:plotArea>
+      <c:layout/>
+      <c:doughnutChart>
+        <c:varyColors val="1"/>
+        <c:ser>
+          <c:idx val="0"/>
+          <c:order val="0"/>
+          <c:tx>
+            <c:strRef>
+              <c:f>Sheet1!$B$1</c:f>
+              <c:strCache>
+                <c:ptCount val="1"/>
+                <c:pt idx="0">
+                  <c:v>컨설팅 유형</c:v>
+                </c:pt>
+              </c:strCache>
+            </c:strRef>
+          </c:tx>
+          <c:spPr>
+            <a:solidFill>
+              <a:schemeClr val="accent1"/>
+            </a:solidFill>
+            <a:ln w="9525" cap="flat">
+              <a:solidFill>
+                <a:srgbClr val="F9F9F9"/>
+              </a:solidFill>
+              <a:prstDash val="solid"/>
+              <a:round/>
+            </a:ln>
+            <a:effectLst/>
+          </c:spPr>
+          <c:dPt>
+            <c:idx val="0"/>
+            <c:bubble3D val="0"/>
+            <c:spPr>
+              <a:solidFill>
+                <a:srgbClr val="1F4E9A"/>
+              </a:solidFill>
+              <a:effectLst/>
+            </c:spPr>
+          </c:dPt>
+          <c:dPt>
+            <c:idx val="1"/>
+            <c:bubble3D val="0"/>
+            <c:spPr>
+              <a:solidFill>
+                <a:srgbClr val="7FA1D6"/>
+              </a:solidFill>
+              <a:effectLst/>
+            </c:spPr>
+          </c:dPt>
+          <c:dPt>
+            <c:idx val="2"/>
+            <c:bubble3D val="0"/>
+            <c:spPr>
+              <a:solidFill>
+                <a:srgbClr val="0F7B6C"/>
+              </a:solidFill>
+              <a:effectLst/>
+            </c:spPr>
+          </c:dPt>
+          <c:dPt>
+            <c:idx val="3"/>
+            <c:bubble3D val="0"/>
+            <c:spPr>
+              <a:solidFill>
+                <a:srgbClr val="D0342C"/>
+              </a:solidFill>
+              <a:effectLst/>
+            </c:spPr>
+          </c:dPt>
+          <c:dLbls>
+            <c:dLbl>
+              <c:idx val="0"/>
+              <c:numFmt formatCode="0%" sourceLinked="0"/>
+              <c:spPr/>
+              <c:txPr>
+                <a:bodyPr/>
+                <a:lstStyle/>
+                <a:p>
+                  <a:pPr>
+                    <a:defRPr sz="900" b="1" i="0" u="none" strike="noStrike">
+                      <a:solidFill>
+                        <a:srgbClr val="FFFFFF"/>
+                      </a:solidFill>
+                      <a:latin typeface="+mn-lt"/>
+                    </a:defRPr>
+                  </a:pPr>
+                </a:p>
+              </c:txPr>
+              <c:showLegendKey val="0"/>
+              <c:showVal val="0"/>
+              <c:showCatName val="0"/>
+              <c:showSerName val="0"/>
+              <c:showPercent val="1"/>
+              <c:showBubbleSize val="0"/>
+            </c:dLbl>
+            <c:dLbl>
+              <c:idx val="1"/>
+              <c:numFmt formatCode="0%" sourceLinked="0"/>
+              <c:spPr/>
+              <c:txPr>
+                <a:bodyPr/>
+                <a:lstStyle/>
+                <a:p>
+                  <a:pPr>
+                    <a:defRPr sz="900" b="1" i="0" u="none" strike="noStrike">
+                      <a:solidFill>
+                        <a:srgbClr val="FFFFFF"/>
+                      </a:solidFill>
+                      <a:latin typeface="+mn-lt"/>
+                    </a:defRPr>
+                  </a:pPr>
+                </a:p>
+              </c:txPr>
+              <c:showLegendKey val="0"/>
+              <c:showVal val="0"/>
+              <c:showCatName val="0"/>
+              <c:showSerName val="0"/>
+              <c:showPercent val="1"/>
+              <c:showBubbleSize val="0"/>
+            </c:dLbl>
+            <c:dLbl>
+              <c:idx val="2"/>
+              <c:numFmt formatCode="0%" sourceLinked="0"/>
+              <c:spPr/>
+              <c:txPr>
+                <a:bodyPr/>
+                <a:lstStyle/>
+                <a:p>
+                  <a:pPr>
+                    <a:defRPr sz="900" b="1" i="0" u="none" strike="noStrike">
+                      <a:solidFill>
+                        <a:srgbClr val="FFFFFF"/>
+                      </a:solidFill>
+                      <a:latin typeface="+mn-lt"/>
+                    </a:defRPr>
+                  </a:pPr>
+                </a:p>
+              </c:txPr>
+              <c:showLegendKey val="0"/>
+              <c:showVal val="0"/>
+              <c:showCatName val="0"/>
+              <c:showSerName val="0"/>
+              <c:showPercent val="1"/>
+              <c:showBubbleSize val="0"/>
+            </c:dLbl>
+            <c:dLbl>
+              <c:idx val="3"/>
+              <c:numFmt formatCode="0%" sourceLinked="0"/>
+              <c:spPr/>
+              <c:txPr>
+                <a:bodyPr/>
+                <a:lstStyle/>
+                <a:p>
+                  <a:pPr>
+                    <a:defRPr sz="900" b="1" i="0" u="none" strike="noStrike">
+                      <a:solidFill>
+                        <a:srgbClr val="FFFFFF"/>
+                      </a:solidFill>
+                      <a:latin typeface="+mn-lt"/>
+                    </a:defRPr>
+                  </a:pPr>
+                </a:p>
+              </c:txPr>
+              <c:showLegendKey val="0"/>
+              <c:showVal val="0"/>
+              <c:showCatName val="0"/>
+              <c:showSerName val="0"/>
+              <c:showPercent val="1"/>
+              <c:showBubbleSize val="0"/>
+            </c:dLbl>
+            <c:numFmt formatCode="0%" sourceLinked="0"/>
+            <c:txPr>
+              <a:bodyPr/>
+              <a:lstStyle/>
+              <a:p>
+                <a:pPr>
+                  <a:defRPr sz="1800" b="1" i="0" u="none" strike="noStrike">
+                    <a:solidFill>
+                      <a:srgbClr val="000000"/>
+                    </a:solidFill>
+                    <a:latin typeface="Arial"/>
+                  </a:defRPr>
+                </a:pPr>
+              </a:p>
+            </c:txPr>
+            <c:showLegendKey val="0"/>
+            <c:showVal val="0"/>
+            <c:showCatName val="1"/>
+            <c:showSerName val="0"/>
+            <c:showPercent val="1"/>
+            <c:showBubbleSize val="0"/>
+            <c:showLeaderLines val="0"/>
+          </c:dLbls>
+          <c:cat>
+            <c:strRef>
+              <c:f>Sheet1!$A$2:$A$5</c:f>
+              <c:strCache>
+                <c:ptCount val="4"/>
+                <c:pt idx="0">
+                  <c:v>AI 진단/과제발굴</c:v>
+                </c:pt>
+                <c:pt idx="1">
+                  <c:v>전문 컨설팅</c:v>
+                </c:pt>
+                <c:pt idx="2">
+                  <c:v>전략수립</c:v>
+                </c:pt>
+                <c:pt idx="3">
+                  <c:v>Pre 컨설팅</c:v>
+                </c:pt>
+              </c:strCache>
+            </c:strRef>
+          </c:cat>
+          <c:val>
+            <c:numRef>
+              <c:f>Sheet1!$B$2:$B$5</c:f>
+              <c:numCache>
+                <c:ptCount val="4"/>
+                <c:pt idx="0">
+                  <c:v>67</c:v>
+                </c:pt>
+                <c:pt idx="1">
+                  <c:v>20</c:v>
+                </c:pt>
+                <c:pt idx="2">
+                  <c:v>7</c:v>
+                </c:pt>
+                <c:pt idx="3">
+                  <c:v>6</c:v>
+                </c:pt>
+              </c:numCache>
+            </c:numRef>
+          </c:val>
+        </c:ser>
+        <c:firstSliceAng val="0"/>
+        <c:holeSize val="55"/>
+      </c:doughnutChart>
+      <c:spPr>
+        <a:noFill/>
+        <a:ln>
+          <a:noFill/>
+        </a:ln>
+        <a:effectLst/>
+      </c:spPr>
+    </c:plotArea>
     <c:plotVisOnly val="1"/>
     <c:dispBlanksAs val="span"/>
   </c:chart>
@@ -1834,7 +2103,7 @@
                   <a:schemeClr val="tx2"/>
                 </a:solidFill>
               </a:rPr>
-              <a:t>25년은 그룹사 AI컨설팅으로 과제를 집중 발굴(77건), 26년은 교육·Camp 신규로 사업 구성이 '발굴'에서 '확산·실행'으로 이동</a:t>
+              <a:t>AI 진단/과제발굴이 컨설팅의 67%를 차지하며 25년 과제 77건을 발굴, 26년은 교육·Camp 신규로 '발굴'에서 '확산·실행'으로 이동</a:t>
             </a:r>
             <a:endParaRPr lang="en-US" sz="1400" dirty="0"/>
           </a:p>
@@ -3952,7 +4221,7 @@
       </p:graphicFrame>
       <p:sp>
         <p:nvSpPr>
-          <p:cNvPr id="8" name="시사점 헤더"/>
+          <p:cNvPr id="8" name="유형 헤더"/>
           <p:cNvSpPr txBox="1"/>
           <p:nvPr/>
         </p:nvSpPr>
@@ -3982,7 +4251,7 @@
                   <a:schemeClr val="bg1"/>
                 </a:solidFill>
               </a:rPr>
-              <a:t>주요 시사점</a:t>
+              <a:t>컨설팅 유형 구성</a:t>
             </a:r>
             <a:endParaRPr lang="en-US" sz="1400" dirty="0"/>
           </a:p>
@@ -3990,14 +4259,481 @@
       </p:sp>
       <p:sp>
         <p:nvSpPr>
-          <p:cNvPr id="9" name="시사점 카드 2025"/>
+          <p:cNvPr id="9" name="유형 패널"/>
           <p:cNvSpPr/>
           <p:nvPr/>
         </p:nvSpPr>
         <p:spPr>
           <a:xfrm>
-            <a:off x="8001000" y="2286000"/>
-            <a:ext cx="3822192" cy="1261872"/>
+            <a:off x="8001000" y="2148840"/>
+            <a:ext cx="3822192" cy="1965960"/>
+          </a:xfrm>
+          <a:prstGeom prst="rect">
+            <a:avLst/>
+          </a:prstGeom>
+          <a:solidFill>
+            <a:schemeClr val="bg1"/>
+          </a:solidFill>
+          <a:ln w="9525">
+            <a:solidFill>
+              <a:srgbClr val="D5D9E0"/>
+            </a:solidFill>
+            <a:prstDash val="solid"/>
+          </a:ln>
+        </p:spPr>
+      </p:sp>
+      <p:graphicFrame>
+        <p:nvGraphicFramePr>
+          <p:cNvPr id="10" name="컨설팅 유형 도넛" descr=""/>
+          <p:cNvGraphicFramePr/>
+          <p:nvPr/>
+        </p:nvGraphicFramePr>
+        <p:xfrm>
+          <a:off x="8046720" y="2194560"/>
+          <a:ext cx="1783080" cy="1874520"/>
+        </p:xfrm>
+        <a:graphic xmlns:a="http://schemas.openxmlformats.org/drawingml/2006/main">
+          <a:graphicData uri="http://schemas.openxmlformats.org/drawingml/2006/chart">
+            <c:chart xmlns:c="http://schemas.openxmlformats.org/drawingml/2006/chart" r:id="rId2"/>
+          </a:graphicData>
+        </a:graphic>
+      </p:graphicFrame>
+      <p:sp>
+        <p:nvSpPr>
+          <p:cNvPr id="11" name="범례 AI 진단/과제발굴"/>
+          <p:cNvSpPr/>
+          <p:nvPr/>
+        </p:nvSpPr>
+        <p:spPr>
+          <a:xfrm>
+            <a:off x="9921240" y="2487168"/>
+            <a:ext cx="146304" cy="146304"/>
+          </a:xfrm>
+          <a:prstGeom prst="rect">
+            <a:avLst/>
+          </a:prstGeom>
+          <a:solidFill>
+            <a:srgbClr val="1F4E9A"/>
+          </a:solidFill>
+          <a:ln w="12700">
+            <a:solidFill>
+              <a:srgbClr val="1F4E9A"/>
+            </a:solidFill>
+            <a:prstDash val="solid"/>
+          </a:ln>
+        </p:spPr>
+      </p:sp>
+      <p:sp>
+        <p:nvSpPr>
+          <p:cNvPr id="12" name="Text 7"/>
+          <p:cNvSpPr txBox="1"/>
+          <p:nvPr/>
+        </p:nvSpPr>
+        <p:spPr>
+          <a:xfrm>
+            <a:off x="10131552" y="2395728"/>
+            <a:ext cx="1143000" cy="329184"/>
+          </a:xfrm>
+          <a:prstGeom prst="rect">
+            <a:avLst/>
+          </a:prstGeom>
+          <a:noFill/>
+          <a:ln/>
+        </p:spPr>
+        <p:txBody>
+          <a:bodyPr wrap="square" lIns="0" tIns="0" rIns="0" bIns="0" rtlCol="0" anchor="ctr"/>
+          <a:lstStyle/>
+          <a:p>
+            <a:pPr indent="0" marL="0">
+              <a:buNone/>
+            </a:pPr>
+            <a:r>
+              <a:rPr lang="en-US" sz="1000" dirty="0">
+                <a:solidFill>
+                  <a:schemeClr val="tx1"/>
+                </a:solidFill>
+              </a:rPr>
+              <a:t>AI 진단/과제발굴</a:t>
+            </a:r>
+            <a:endParaRPr lang="en-US" sz="1000" dirty="0"/>
+          </a:p>
+        </p:txBody>
+      </p:sp>
+      <p:sp>
+        <p:nvSpPr>
+          <p:cNvPr id="13" name="Text 8"/>
+          <p:cNvSpPr txBox="1"/>
+          <p:nvPr/>
+        </p:nvSpPr>
+        <p:spPr>
+          <a:xfrm>
+            <a:off x="11201400" y="2395728"/>
+            <a:ext cx="548640" cy="329184"/>
+          </a:xfrm>
+          <a:prstGeom prst="rect">
+            <a:avLst/>
+          </a:prstGeom>
+          <a:noFill/>
+          <a:ln/>
+        </p:spPr>
+        <p:txBody>
+          <a:bodyPr wrap="square" lIns="0" tIns="0" rIns="0" bIns="0" rtlCol="0" anchor="ctr"/>
+          <a:lstStyle/>
+          <a:p>
+            <a:pPr algn="r" indent="0" marL="0">
+              <a:buNone/>
+            </a:pPr>
+            <a:r>
+              <a:rPr lang="en-US" sz="1200" b="1" dirty="0">
+                <a:solidFill>
+                  <a:schemeClr val="tx2"/>
+                </a:solidFill>
+              </a:rPr>
+              <a:t>67%</a:t>
+            </a:r>
+            <a:endParaRPr lang="en-US" sz="1200" dirty="0"/>
+          </a:p>
+        </p:txBody>
+      </p:sp>
+      <p:sp>
+        <p:nvSpPr>
+          <p:cNvPr id="14" name="범례 전문 컨설팅"/>
+          <p:cNvSpPr/>
+          <p:nvPr/>
+        </p:nvSpPr>
+        <p:spPr>
+          <a:xfrm>
+            <a:off x="9921240" y="2889504"/>
+            <a:ext cx="146304" cy="146304"/>
+          </a:xfrm>
+          <a:prstGeom prst="rect">
+            <a:avLst/>
+          </a:prstGeom>
+          <a:solidFill>
+            <a:srgbClr val="7FA1D6"/>
+          </a:solidFill>
+          <a:ln w="12700">
+            <a:solidFill>
+              <a:srgbClr val="7FA1D6"/>
+            </a:solidFill>
+            <a:prstDash val="solid"/>
+          </a:ln>
+        </p:spPr>
+      </p:sp>
+      <p:sp>
+        <p:nvSpPr>
+          <p:cNvPr id="15" name="Text 10"/>
+          <p:cNvSpPr txBox="1"/>
+          <p:nvPr/>
+        </p:nvSpPr>
+        <p:spPr>
+          <a:xfrm>
+            <a:off x="10131552" y="2798064"/>
+            <a:ext cx="1143000" cy="329184"/>
+          </a:xfrm>
+          <a:prstGeom prst="rect">
+            <a:avLst/>
+          </a:prstGeom>
+          <a:noFill/>
+          <a:ln/>
+        </p:spPr>
+        <p:txBody>
+          <a:bodyPr wrap="square" lIns="0" tIns="0" rIns="0" bIns="0" rtlCol="0" anchor="ctr"/>
+          <a:lstStyle/>
+          <a:p>
+            <a:pPr indent="0" marL="0">
+              <a:buNone/>
+            </a:pPr>
+            <a:r>
+              <a:rPr lang="en-US" sz="1000" dirty="0">
+                <a:solidFill>
+                  <a:schemeClr val="tx1"/>
+                </a:solidFill>
+              </a:rPr>
+              <a:t>전문 컨설팅</a:t>
+            </a:r>
+            <a:endParaRPr lang="en-US" sz="1000" dirty="0"/>
+          </a:p>
+        </p:txBody>
+      </p:sp>
+      <p:sp>
+        <p:nvSpPr>
+          <p:cNvPr id="16" name="Text 11"/>
+          <p:cNvSpPr txBox="1"/>
+          <p:nvPr/>
+        </p:nvSpPr>
+        <p:spPr>
+          <a:xfrm>
+            <a:off x="11201400" y="2798064"/>
+            <a:ext cx="548640" cy="329184"/>
+          </a:xfrm>
+          <a:prstGeom prst="rect">
+            <a:avLst/>
+          </a:prstGeom>
+          <a:noFill/>
+          <a:ln/>
+        </p:spPr>
+        <p:txBody>
+          <a:bodyPr wrap="square" lIns="0" tIns="0" rIns="0" bIns="0" rtlCol="0" anchor="ctr"/>
+          <a:lstStyle/>
+          <a:p>
+            <a:pPr algn="r" indent="0" marL="0">
+              <a:buNone/>
+            </a:pPr>
+            <a:r>
+              <a:rPr lang="en-US" sz="1200" b="1" dirty="0">
+                <a:solidFill>
+                  <a:schemeClr val="tx2"/>
+                </a:solidFill>
+              </a:rPr>
+              <a:t>20%</a:t>
+            </a:r>
+            <a:endParaRPr lang="en-US" sz="1200" dirty="0"/>
+          </a:p>
+        </p:txBody>
+      </p:sp>
+      <p:sp>
+        <p:nvSpPr>
+          <p:cNvPr id="17" name="범례 전략수립"/>
+          <p:cNvSpPr/>
+          <p:nvPr/>
+        </p:nvSpPr>
+        <p:spPr>
+          <a:xfrm>
+            <a:off x="9921240" y="3291840"/>
+            <a:ext cx="146304" cy="146304"/>
+          </a:xfrm>
+          <a:prstGeom prst="rect">
+            <a:avLst/>
+          </a:prstGeom>
+          <a:solidFill>
+            <a:srgbClr val="0F7B6C"/>
+          </a:solidFill>
+          <a:ln w="12700">
+            <a:solidFill>
+              <a:srgbClr val="0F7B6C"/>
+            </a:solidFill>
+            <a:prstDash val="solid"/>
+          </a:ln>
+        </p:spPr>
+      </p:sp>
+      <p:sp>
+        <p:nvSpPr>
+          <p:cNvPr id="18" name="Text 13"/>
+          <p:cNvSpPr txBox="1"/>
+          <p:nvPr/>
+        </p:nvSpPr>
+        <p:spPr>
+          <a:xfrm>
+            <a:off x="10131552" y="3200400"/>
+            <a:ext cx="1143000" cy="329184"/>
+          </a:xfrm>
+          <a:prstGeom prst="rect">
+            <a:avLst/>
+          </a:prstGeom>
+          <a:noFill/>
+          <a:ln/>
+        </p:spPr>
+        <p:txBody>
+          <a:bodyPr wrap="square" lIns="0" tIns="0" rIns="0" bIns="0" rtlCol="0" anchor="ctr"/>
+          <a:lstStyle/>
+          <a:p>
+            <a:pPr indent="0" marL="0">
+              <a:buNone/>
+            </a:pPr>
+            <a:r>
+              <a:rPr lang="en-US" sz="1000" dirty="0">
+                <a:solidFill>
+                  <a:schemeClr val="tx1"/>
+                </a:solidFill>
+              </a:rPr>
+              <a:t>전략수립</a:t>
+            </a:r>
+            <a:endParaRPr lang="en-US" sz="1000" dirty="0"/>
+          </a:p>
+        </p:txBody>
+      </p:sp>
+      <p:sp>
+        <p:nvSpPr>
+          <p:cNvPr id="19" name="Text 14"/>
+          <p:cNvSpPr txBox="1"/>
+          <p:nvPr/>
+        </p:nvSpPr>
+        <p:spPr>
+          <a:xfrm>
+            <a:off x="11201400" y="3200400"/>
+            <a:ext cx="548640" cy="329184"/>
+          </a:xfrm>
+          <a:prstGeom prst="rect">
+            <a:avLst/>
+          </a:prstGeom>
+          <a:noFill/>
+          <a:ln/>
+        </p:spPr>
+        <p:txBody>
+          <a:bodyPr wrap="square" lIns="0" tIns="0" rIns="0" bIns="0" rtlCol="0" anchor="ctr"/>
+          <a:lstStyle/>
+          <a:p>
+            <a:pPr algn="r" indent="0" marL="0">
+              <a:buNone/>
+            </a:pPr>
+            <a:r>
+              <a:rPr lang="en-US" sz="1200" b="1" dirty="0">
+                <a:solidFill>
+                  <a:schemeClr val="tx2"/>
+                </a:solidFill>
+              </a:rPr>
+              <a:t>7%</a:t>
+            </a:r>
+            <a:endParaRPr lang="en-US" sz="1200" dirty="0"/>
+          </a:p>
+        </p:txBody>
+      </p:sp>
+      <p:sp>
+        <p:nvSpPr>
+          <p:cNvPr id="20" name="범례 Pre 컨설팅"/>
+          <p:cNvSpPr/>
+          <p:nvPr/>
+        </p:nvSpPr>
+        <p:spPr>
+          <a:xfrm>
+            <a:off x="9921240" y="3694176"/>
+            <a:ext cx="146304" cy="146304"/>
+          </a:xfrm>
+          <a:prstGeom prst="rect">
+            <a:avLst/>
+          </a:prstGeom>
+          <a:solidFill>
+            <a:srgbClr val="D0342C"/>
+          </a:solidFill>
+          <a:ln w="12700">
+            <a:solidFill>
+              <a:srgbClr val="D0342C"/>
+            </a:solidFill>
+            <a:prstDash val="solid"/>
+          </a:ln>
+        </p:spPr>
+      </p:sp>
+      <p:sp>
+        <p:nvSpPr>
+          <p:cNvPr id="21" name="Text 16"/>
+          <p:cNvSpPr txBox="1"/>
+          <p:nvPr/>
+        </p:nvSpPr>
+        <p:spPr>
+          <a:xfrm>
+            <a:off x="10131552" y="3602736"/>
+            <a:ext cx="1143000" cy="329184"/>
+          </a:xfrm>
+          <a:prstGeom prst="rect">
+            <a:avLst/>
+          </a:prstGeom>
+          <a:noFill/>
+          <a:ln/>
+        </p:spPr>
+        <p:txBody>
+          <a:bodyPr wrap="square" lIns="0" tIns="0" rIns="0" bIns="0" rtlCol="0" anchor="ctr"/>
+          <a:lstStyle/>
+          <a:p>
+            <a:pPr indent="0" marL="0">
+              <a:buNone/>
+            </a:pPr>
+            <a:r>
+              <a:rPr lang="en-US" sz="1000" dirty="0">
+                <a:solidFill>
+                  <a:schemeClr val="tx1"/>
+                </a:solidFill>
+              </a:rPr>
+              <a:t>Pre 컨설팅</a:t>
+            </a:r>
+            <a:endParaRPr lang="en-US" sz="1000" dirty="0"/>
+          </a:p>
+        </p:txBody>
+      </p:sp>
+      <p:sp>
+        <p:nvSpPr>
+          <p:cNvPr id="22" name="Text 17"/>
+          <p:cNvSpPr txBox="1"/>
+          <p:nvPr/>
+        </p:nvSpPr>
+        <p:spPr>
+          <a:xfrm>
+            <a:off x="11201400" y="3602736"/>
+            <a:ext cx="548640" cy="329184"/>
+          </a:xfrm>
+          <a:prstGeom prst="rect">
+            <a:avLst/>
+          </a:prstGeom>
+          <a:noFill/>
+          <a:ln/>
+        </p:spPr>
+        <p:txBody>
+          <a:bodyPr wrap="square" lIns="0" tIns="0" rIns="0" bIns="0" rtlCol="0" anchor="ctr"/>
+          <a:lstStyle/>
+          <a:p>
+            <a:pPr algn="r" indent="0" marL="0">
+              <a:buNone/>
+            </a:pPr>
+            <a:r>
+              <a:rPr lang="en-US" sz="1200" b="1" dirty="0">
+                <a:solidFill>
+                  <a:schemeClr val="tx2"/>
+                </a:solidFill>
+              </a:rPr>
+              <a:t>6%</a:t>
+            </a:r>
+            <a:endParaRPr lang="en-US" sz="1200" dirty="0"/>
+          </a:p>
+        </p:txBody>
+      </p:sp>
+      <p:sp>
+        <p:nvSpPr>
+          <p:cNvPr id="23" name="시사점 헤더"/>
+          <p:cNvSpPr txBox="1"/>
+          <p:nvPr/>
+        </p:nvSpPr>
+        <p:spPr>
+          <a:xfrm>
+            <a:off x="8001000" y="4315968"/>
+            <a:ext cx="3822192" cy="365760"/>
+          </a:xfrm>
+          <a:prstGeom prst="rect">
+            <a:avLst/>
+          </a:prstGeom>
+          <a:solidFill>
+            <a:schemeClr val="tx2"/>
+          </a:solidFill>
+          <a:ln/>
+        </p:spPr>
+        <p:txBody>
+          <a:bodyPr wrap="square" rtlCol="0" anchor="ctr"/>
+          <a:lstStyle/>
+          <a:p>
+            <a:pPr algn="ctr" indent="0" marL="0">
+              <a:buNone/>
+            </a:pPr>
+            <a:r>
+              <a:rPr lang="en-US" sz="1300" b="1" dirty="0">
+                <a:solidFill>
+                  <a:schemeClr val="bg1"/>
+                </a:solidFill>
+              </a:rPr>
+              <a:t>주요 시사점</a:t>
+            </a:r>
+            <a:endParaRPr lang="en-US" sz="1300" dirty="0"/>
+          </a:p>
+        </p:txBody>
+      </p:sp>
+      <p:sp>
+        <p:nvSpPr>
+          <p:cNvPr id="24" name="시사점 카드 2025"/>
+          <p:cNvSpPr/>
+          <p:nvPr/>
+        </p:nvSpPr>
+        <p:spPr>
+          <a:xfrm>
+            <a:off x="8001000" y="4754880"/>
+            <a:ext cx="3822192" cy="493776"/>
           </a:xfrm>
           <a:prstGeom prst="rect">
             <a:avLst/>
@@ -4015,14 +4751,14 @@
       </p:sp>
       <p:sp>
         <p:nvSpPr>
-          <p:cNvPr id="10" name="연도 원 2025"/>
+          <p:cNvPr id="25" name="연도 원 2025"/>
           <p:cNvSpPr/>
           <p:nvPr/>
         </p:nvSpPr>
         <p:spPr>
           <a:xfrm>
-            <a:off x="8138160" y="2423160"/>
-            <a:ext cx="713232" cy="713232"/>
+            <a:off x="8092440" y="4809744"/>
+            <a:ext cx="384048" cy="384048"/>
           </a:xfrm>
           <a:prstGeom prst="ellipse">
             <a:avLst/>
@@ -4040,14 +4776,14 @@
       </p:sp>
       <p:sp>
         <p:nvSpPr>
-          <p:cNvPr id="11" name="Text 7"/>
+          <p:cNvPr id="26" name="Text 21"/>
           <p:cNvSpPr txBox="1"/>
           <p:nvPr/>
         </p:nvSpPr>
         <p:spPr>
           <a:xfrm>
-            <a:off x="8138160" y="2423160"/>
-            <a:ext cx="713232" cy="713232"/>
+            <a:off x="8092440" y="4809744"/>
+            <a:ext cx="384048" cy="384048"/>
           </a:xfrm>
           <a:prstGeom prst="rect">
             <a:avLst/>
@@ -4063,27 +4799,27 @@
               <a:buNone/>
             </a:pPr>
             <a:r>
-              <a:rPr lang="en-US" sz="1400" b="1" dirty="0">
+              <a:rPr lang="en-US" sz="1100" b="1" dirty="0">
                 <a:solidFill>
                   <a:schemeClr val="bg1"/>
                 </a:solidFill>
               </a:rPr>
-              <a:t>2025</a:t>
+              <a:t>25</a:t>
             </a:r>
-            <a:endParaRPr lang="en-US" sz="1400" dirty="0"/>
+            <a:endParaRPr lang="en-US" sz="1100" dirty="0"/>
           </a:p>
         </p:txBody>
       </p:sp>
       <p:sp>
         <p:nvSpPr>
-          <p:cNvPr id="12" name="Text 8"/>
+          <p:cNvPr id="27" name="Text 22"/>
           <p:cNvSpPr txBox="1"/>
           <p:nvPr/>
         </p:nvSpPr>
         <p:spPr>
           <a:xfrm>
-            <a:off x="8961120" y="2395728"/>
-            <a:ext cx="2770632" cy="292608"/>
+            <a:off x="8567928" y="4754880"/>
+            <a:ext cx="3182112" cy="493776"/>
           </a:xfrm>
           <a:prstGeom prst="rect">
             <a:avLst/>
@@ -4099,77 +4835,41 @@
               <a:buNone/>
             </a:pPr>
             <a:r>
-              <a:rPr lang="en-US" sz="1300" b="1" dirty="0">
+              <a:rPr lang="en-US" sz="1100" b="1" dirty="0">
                 <a:solidFill>
                   <a:schemeClr val="accent1"/>
                 </a:solidFill>
               </a:rPr>
               <a:t>발굴기</a:t>
             </a:r>
-            <a:endParaRPr lang="en-US" sz="1300" dirty="0"/>
-          </a:p>
-        </p:txBody>
-      </p:sp>
-      <p:sp>
-        <p:nvSpPr>
-          <p:cNvPr id="13" name="Text 9"/>
-          <p:cNvSpPr txBox="1"/>
-          <p:nvPr/>
-        </p:nvSpPr>
-        <p:spPr>
-          <a:xfrm>
-            <a:off x="8961120" y="2697480"/>
-            <a:ext cx="2770632" cy="804672"/>
-          </a:xfrm>
-          <a:prstGeom prst="rect">
-            <a:avLst/>
-          </a:prstGeom>
-          <a:noFill/>
-          <a:ln/>
-        </p:spPr>
-        <p:txBody>
-          <a:bodyPr wrap="square" lIns="0" tIns="0" rIns="0" bIns="0" rtlCol="0" anchor="t"/>
-          <a:lstStyle/>
-          <a:p>
-            <a:pPr indent="0" marL="0">
-              <a:buNone/>
-            </a:pPr>
-            <a:r>
-              <a:rPr lang="en-US" sz="1050" dirty="0">
-                <a:solidFill>
-                  <a:schemeClr val="tx1"/>
-                </a:solidFill>
-              </a:rPr>
-              <a:t>그룹사 AI컨설팅 13건 중심</a:t>
-            </a:r>
-            <a:endParaRPr lang="en-US" sz="1050" dirty="0"/>
+            <a:endParaRPr lang="en-US" sz="1100" dirty="0"/>
           </a:p>
           <a:p>
             <a:pPr indent="0" marL="0">
               <a:buNone/>
             </a:pPr>
             <a:r>
-              <a:rPr lang="en-US" sz="1050" dirty="0">
+              <a:rPr lang="en-US" sz="950" dirty="0">
                 <a:solidFill>
                   <a:schemeClr val="tx1"/>
                 </a:solidFill>
               </a:rPr>
-              <a:t>프로젝트 15건 · AI과제 77건 발굴</a:t>
+              <a:t>AI컨설팅 15건 · 과제 77건, 진단/발굴 67%</a:t>
             </a:r>
-            <a:endParaRPr lang="en-US" sz="1050" dirty="0"/>
+            <a:endParaRPr lang="en-US" sz="1100" dirty="0"/>
           </a:p>
         </p:txBody>
       </p:sp>
       <p:sp>
         <p:nvSpPr>
-          <p:cNvPr id="14" name="시사점 카드 2026"/>
+          <p:cNvPr id="28" name="시사점 카드 2026"/>
           <p:cNvSpPr/>
           <p:nvPr/>
         </p:nvSpPr>
         <p:spPr>
           <a:xfrm>
-            <a:off x="8001000" y="3657600"/>
-            <a:ext cx="3822192" cy="1261872"/>
+            <a:off x="8001000" y="5303520"/>
+            <a:ext cx="3822192" cy="493776"/>
           </a:xfrm>
           <a:prstGeom prst="rect">
             <a:avLst/>
@@ -4187,14 +4887,14 @@
       </p:sp>
       <p:sp>
         <p:nvSpPr>
-          <p:cNvPr id="15" name="연도 원 2026"/>
+          <p:cNvPr id="29" name="연도 원 2026"/>
           <p:cNvSpPr/>
           <p:nvPr/>
         </p:nvSpPr>
         <p:spPr>
           <a:xfrm>
-            <a:off x="8138160" y="3794760"/>
-            <a:ext cx="713232" cy="713232"/>
+            <a:off x="8092440" y="5358384"/>
+            <a:ext cx="384048" cy="384048"/>
           </a:xfrm>
           <a:prstGeom prst="ellipse">
             <a:avLst/>
@@ -4212,14 +4912,14 @@
       </p:sp>
       <p:sp>
         <p:nvSpPr>
-          <p:cNvPr id="16" name="Text 12"/>
+          <p:cNvPr id="30" name="Text 25"/>
           <p:cNvSpPr txBox="1"/>
           <p:nvPr/>
         </p:nvSpPr>
         <p:spPr>
           <a:xfrm>
-            <a:off x="8138160" y="3794760"/>
-            <a:ext cx="713232" cy="713232"/>
+            <a:off x="8092440" y="5358384"/>
+            <a:ext cx="384048" cy="384048"/>
           </a:xfrm>
           <a:prstGeom prst="rect">
             <a:avLst/>
@@ -4235,27 +4935,27 @@
               <a:buNone/>
             </a:pPr>
             <a:r>
-              <a:rPr lang="en-US" sz="1400" b="1" dirty="0">
+              <a:rPr lang="en-US" sz="1100" b="1" dirty="0">
                 <a:solidFill>
                   <a:schemeClr val="bg1"/>
                 </a:solidFill>
               </a:rPr>
-              <a:t>2026</a:t>
+              <a:t>26</a:t>
             </a:r>
-            <a:endParaRPr lang="en-US" sz="1400" dirty="0"/>
+            <a:endParaRPr lang="en-US" sz="1100" dirty="0"/>
           </a:p>
         </p:txBody>
       </p:sp>
       <p:sp>
         <p:nvSpPr>
-          <p:cNvPr id="17" name="Text 13"/>
+          <p:cNvPr id="31" name="Text 26"/>
           <p:cNvSpPr txBox="1"/>
           <p:nvPr/>
         </p:nvSpPr>
         <p:spPr>
           <a:xfrm>
-            <a:off x="8961120" y="3767328"/>
-            <a:ext cx="2770632" cy="292608"/>
+            <a:off x="8567928" y="5303520"/>
+            <a:ext cx="3182112" cy="493776"/>
           </a:xfrm>
           <a:prstGeom prst="rect">
             <a:avLst/>
@@ -4271,91 +4971,41 @@
               <a:buNone/>
             </a:pPr>
             <a:r>
-              <a:rPr lang="en-US" sz="1300" b="1" dirty="0">
+              <a:rPr lang="en-US" sz="1100" b="1" dirty="0">
                 <a:solidFill>
                   <a:schemeClr val="accent6"/>
                 </a:solidFill>
               </a:rPr>
               <a:t>확산·전환기</a:t>
             </a:r>
-            <a:endParaRPr lang="en-US" sz="1300" dirty="0"/>
-          </a:p>
-        </p:txBody>
-      </p:sp>
-      <p:sp>
-        <p:nvSpPr>
-          <p:cNvPr id="18" name="Text 14"/>
-          <p:cNvSpPr txBox="1"/>
-          <p:nvPr/>
-        </p:nvSpPr>
-        <p:spPr>
-          <a:xfrm>
-            <a:off x="8961120" y="4069080"/>
-            <a:ext cx="2770632" cy="804672"/>
-          </a:xfrm>
-          <a:prstGeom prst="rect">
-            <a:avLst/>
-          </a:prstGeom>
-          <a:noFill/>
-          <a:ln/>
-        </p:spPr>
-        <p:txBody>
-          <a:bodyPr wrap="square" lIns="0" tIns="0" rIns="0" bIns="0" rtlCol="0" anchor="t"/>
-          <a:lstStyle/>
-          <a:p>
-            <a:pPr indent="0" marL="0">
-              <a:buNone/>
-            </a:pPr>
-            <a:r>
-              <a:rPr lang="en-US" sz="1050" dirty="0">
-                <a:solidFill>
-                  <a:schemeClr val="tx1"/>
-                </a:solidFill>
-              </a:rPr>
-              <a:t>교육·Camp 6건 신규 (그룹사 5 · 대외 1)</a:t>
-            </a:r>
-            <a:endParaRPr lang="en-US" sz="1050" dirty="0"/>
+            <a:endParaRPr lang="en-US" sz="1100" dirty="0"/>
           </a:p>
           <a:p>
             <a:pPr indent="0" marL="0">
               <a:buNone/>
             </a:pPr>
             <a:r>
-              <a:rPr lang="en-US" sz="1050" dirty="0">
+              <a:rPr lang="en-US" sz="950" dirty="0">
                 <a:solidFill>
                   <a:schemeClr val="tx1"/>
                 </a:solidFill>
               </a:rPr>
-              <a:t>컨설팅은 수주 연계형으로 전환</a:t>
+              <a:t>교육·Camp 6건 신규, Pre컨설팅 → 수주 연계</a:t>
             </a:r>
-            <a:endParaRPr lang="en-US" sz="1050" dirty="0"/>
-          </a:p>
-          <a:p>
-            <a:pPr indent="0" marL="0">
-              <a:buNone/>
-            </a:pPr>
-            <a:r>
-              <a:rPr lang="en-US" sz="1050" dirty="0">
-                <a:solidFill>
-                  <a:schemeClr val="tx1"/>
-                </a:solidFill>
-              </a:rPr>
-              <a:t>(신분당선 129억 수주, '27 연계 확보)</a:t>
-            </a:r>
-            <a:endParaRPr lang="en-US" sz="1050" dirty="0"/>
+            <a:endParaRPr lang="en-US" sz="1100" dirty="0"/>
           </a:p>
         </p:txBody>
       </p:sp>
       <p:sp>
         <p:nvSpPr>
-          <p:cNvPr id="19" name="시사점 카드 2027"/>
+          <p:cNvPr id="32" name="시사점 카드 2027"/>
           <p:cNvSpPr/>
           <p:nvPr/>
         </p:nvSpPr>
         <p:spPr>
           <a:xfrm>
-            <a:off x="8001000" y="5029200"/>
-            <a:ext cx="3822192" cy="1261872"/>
+            <a:off x="8001000" y="5852160"/>
+            <a:ext cx="3822192" cy="493776"/>
           </a:xfrm>
           <a:prstGeom prst="rect">
             <a:avLst/>
@@ -4373,14 +5023,14 @@
       </p:sp>
       <p:sp>
         <p:nvSpPr>
-          <p:cNvPr id="20" name="연도 원 2027"/>
+          <p:cNvPr id="33" name="연도 원 2027"/>
           <p:cNvSpPr/>
           <p:nvPr/>
         </p:nvSpPr>
         <p:spPr>
           <a:xfrm>
-            <a:off x="8138160" y="5166360"/>
-            <a:ext cx="713232" cy="713232"/>
+            <a:off x="8092440" y="5907024"/>
+            <a:ext cx="384048" cy="384048"/>
           </a:xfrm>
           <a:prstGeom prst="ellipse">
             <a:avLst/>
@@ -4398,14 +5048,14 @@
       </p:sp>
       <p:sp>
         <p:nvSpPr>
-          <p:cNvPr id="21" name="Text 17"/>
+          <p:cNvPr id="34" name="Text 29"/>
           <p:cNvSpPr txBox="1"/>
           <p:nvPr/>
         </p:nvSpPr>
         <p:spPr>
           <a:xfrm>
-            <a:off x="8138160" y="5166360"/>
-            <a:ext cx="713232" cy="713232"/>
+            <a:off x="8092440" y="5907024"/>
+            <a:ext cx="384048" cy="384048"/>
           </a:xfrm>
           <a:prstGeom prst="rect">
             <a:avLst/>
@@ -4421,27 +5071,27 @@
               <a:buNone/>
             </a:pPr>
             <a:r>
-              <a:rPr lang="en-US" sz="1400" b="1" dirty="0">
+              <a:rPr lang="en-US" sz="1100" b="1" dirty="0">
                 <a:solidFill>
                   <a:schemeClr val="bg1"/>
                 </a:solidFill>
               </a:rPr>
-              <a:t>2027</a:t>
+              <a:t>27</a:t>
             </a:r>
-            <a:endParaRPr lang="en-US" sz="1400" dirty="0"/>
+            <a:endParaRPr lang="en-US" sz="1100" dirty="0"/>
           </a:p>
         </p:txBody>
       </p:sp>
       <p:sp>
         <p:nvSpPr>
-          <p:cNvPr id="22" name="Text 18"/>
+          <p:cNvPr id="35" name="Text 30"/>
           <p:cNvSpPr txBox="1"/>
           <p:nvPr/>
         </p:nvSpPr>
         <p:spPr>
           <a:xfrm>
-            <a:off x="8961120" y="5138928"/>
-            <a:ext cx="2770632" cy="292608"/>
+            <a:off x="8567928" y="5852160"/>
+            <a:ext cx="3182112" cy="493776"/>
           </a:xfrm>
           <a:prstGeom prst="rect">
             <a:avLst/>
@@ -4457,70 +5107,34 @@
               <a:buNone/>
             </a:pPr>
             <a:r>
-              <a:rPr lang="en-US" sz="1300" b="1" dirty="0">
+              <a:rPr lang="en-US" sz="1100" b="1" dirty="0">
                 <a:solidFill>
                   <a:schemeClr val="accent2"/>
                 </a:solidFill>
               </a:rPr>
-              <a:t>실행기 (제안)</a:t>
+              <a:t>실행기(제안)</a:t>
             </a:r>
-            <a:endParaRPr lang="en-US" sz="1300" dirty="0"/>
-          </a:p>
-        </p:txBody>
-      </p:sp>
-      <p:sp>
-        <p:nvSpPr>
-          <p:cNvPr id="23" name="Text 19"/>
-          <p:cNvSpPr txBox="1"/>
-          <p:nvPr/>
-        </p:nvSpPr>
-        <p:spPr>
-          <a:xfrm>
-            <a:off x="8961120" y="5440680"/>
-            <a:ext cx="2770632" cy="804672"/>
-          </a:xfrm>
-          <a:prstGeom prst="rect">
-            <a:avLst/>
-          </a:prstGeom>
-          <a:noFill/>
-          <a:ln/>
-        </p:spPr>
-        <p:txBody>
-          <a:bodyPr wrap="square" lIns="0" tIns="0" rIns="0" bIns="0" rtlCol="0" anchor="t"/>
-          <a:lstStyle/>
-          <a:p>
-            <a:pPr indent="0" marL="0">
-              <a:buNone/>
-            </a:pPr>
-            <a:r>
-              <a:rPr lang="en-US" sz="1050" dirty="0">
-                <a:solidFill>
-                  <a:schemeClr val="tx1"/>
-                </a:solidFill>
-              </a:rPr>
-              <a:t>AX CAMP로 과제 발굴 → FDE로 구현</a:t>
-            </a:r>
-            <a:endParaRPr lang="en-US" sz="1050" dirty="0"/>
+            <a:endParaRPr lang="en-US" sz="1100" dirty="0"/>
           </a:p>
           <a:p>
             <a:pPr indent="0" marL="0">
               <a:buNone/>
             </a:pPr>
             <a:r>
-              <a:rPr lang="en-US" sz="1050" dirty="0">
+              <a:rPr lang="en-US" sz="950" dirty="0">
                 <a:solidFill>
                   <a:schemeClr val="tx1"/>
                 </a:solidFill>
               </a:rPr>
-              <a:t>발굴 과제를 실행·성과로 연결</a:t>
+              <a:t>AX CAMP 발굴 → FDE 구현으로 성과 연결</a:t>
             </a:r>
-            <a:endParaRPr lang="en-US" sz="1050" dirty="0"/>
+            <a:endParaRPr lang="en-US" sz="1100" dirty="0"/>
           </a:p>
         </p:txBody>
       </p:sp>
       <p:sp>
         <p:nvSpPr>
-          <p:cNvPr id="24" name="Text 20"/>
+          <p:cNvPr id="36" name="Text 31"/>
           <p:cNvSpPr txBox="1"/>
           <p:nvPr/>
         </p:nvSpPr>

</xml_diff>